<commit_message>
Finalize independent review and sync verified submission candidate
</commit_message>
<xml_diff>
--- a/artifacts/presentation/Presentation.pptx
+++ b/artifacts/presentation/Presentation.pptx
@@ -2,18 +2,18 @@
 <file path=ppt/presentation.xml><?xml version="1.0" encoding="utf-8"?>
 <p:presentation xmlns:p="http://schemas.openxmlformats.org/presentationml/2006/main">
   <p:sldMasterIdLst>
-    <p:sldMasterId xmlns:r="http://schemas.openxmlformats.org/officeDocument/2006/relationships" id="2147483648" r:id="Rd41520563d054ba6"/>
+    <p:sldMasterId xmlns:r="http://schemas.openxmlformats.org/officeDocument/2006/relationships" id="2147483648" r:id="Rd1855f23126643f0"/>
   </p:sldMasterIdLst>
   <p:notesMasterIdLst>
-    <p:notesMasterId xmlns:r="http://schemas.openxmlformats.org/officeDocument/2006/relationships" r:id="R63d27d2a2b9a4fd3"/>
+    <p:notesMasterId xmlns:r="http://schemas.openxmlformats.org/officeDocument/2006/relationships" r:id="R6dffc6a71ba641e5"/>
   </p:notesMasterIdLst>
   <p:sldIdLst>
-    <p:sldId xmlns:r="http://schemas.openxmlformats.org/officeDocument/2006/relationships" id="256" r:id="R63c821c0769f459e"/>
-    <p:sldId xmlns:r="http://schemas.openxmlformats.org/officeDocument/2006/relationships" id="257" r:id="Rc1b9b9bf407c4c18"/>
-    <p:sldId xmlns:r="http://schemas.openxmlformats.org/officeDocument/2006/relationships" id="258" r:id="R65fb15985a4748d7"/>
-    <p:sldId xmlns:r="http://schemas.openxmlformats.org/officeDocument/2006/relationships" id="259" r:id="Ra2a6cdfd001e4945"/>
-    <p:sldId xmlns:r="http://schemas.openxmlformats.org/officeDocument/2006/relationships" id="260" r:id="R47d69629940f417a"/>
-    <p:sldId xmlns:r="http://schemas.openxmlformats.org/officeDocument/2006/relationships" id="261" r:id="R352076aa94ea4a24"/>
+    <p:sldId xmlns:r="http://schemas.openxmlformats.org/officeDocument/2006/relationships" id="256" r:id="R6b59b217a76a4a4b"/>
+    <p:sldId xmlns:r="http://schemas.openxmlformats.org/officeDocument/2006/relationships" id="257" r:id="R80d1108657b04df6"/>
+    <p:sldId xmlns:r="http://schemas.openxmlformats.org/officeDocument/2006/relationships" id="258" r:id="R2f61f0a200c14ed3"/>
+    <p:sldId xmlns:r="http://schemas.openxmlformats.org/officeDocument/2006/relationships" id="259" r:id="Rab5a167c3a6f4b11"/>
+    <p:sldId xmlns:r="http://schemas.openxmlformats.org/officeDocument/2006/relationships" id="260" r:id="Re41462203bfa4811"/>
+    <p:sldId xmlns:r="http://schemas.openxmlformats.org/officeDocument/2006/relationships" id="261" r:id="R72b7976f67864591"/>
   </p:sldIdLst>
   <p:sldSz cx="12192000" cy="6858000"/>
   <p:notesSz cx="6858000" cy="9144000"/>
@@ -447,7 +447,7 @@
           <a:lstStyle xmlns:a="http://schemas.openxmlformats.org/drawingml/2006/main"/>
           <a:p xmlns:a="http://schemas.openxmlformats.org/drawingml/2006/main">
             <a:r>
-              <a:t>Source: docs/srs/SRS.md; docs/reports/code-freeze.md. Group number 89 supplied by the user. Full frozen SHA: 4d3508db0447a3ac6346a2a2789da89208f88fd5. Speaker: MEMBER_A.</a:t>
+              <a:t>Sources: docs/srs/SRS.md; submission/manifest.md. Working-tree review candidate, not a final submission. AI-assisted content requires the group to review and declare it. Planned speaker: MEMBER_A.</a:t>
             </a:r>
           </a:p>
         </p:txBody>
@@ -587,7 +587,7 @@
           <a:lstStyle xmlns:a="http://schemas.openxmlformats.org/drawingml/2006/main"/>
           <a:p xmlns:a="http://schemas.openxmlformats.org/drawingml/2006/main">
             <a:r>
-              <a:t>Sources: docs/srs/SRS.md FR-26, FR-28, FR-29, FR-31, FR-33, FR-34, FR-36; docs/manuals/User_Manual.md §5; frozen src/model/search.py. Speaker: MEMBER_B.</a:t>
+              <a:t>Sources: docs/srs/SRS.md FR-26, FR-28, FR-29, FR-31, FR-33, FR-34, FR-36; docs/manuals/User_Manual.md §5; current src/model/search.py. Speaker: MEMBER_B.</a:t>
             </a:r>
           </a:p>
         </p:txBody>
@@ -727,7 +727,7 @@
           <a:lstStyle xmlns:a="http://schemas.openxmlformats.org/drawingml/2006/main"/>
           <a:p xmlns:a="http://schemas.openxmlformats.org/drawingml/2006/main">
             <a:r>
-              <a:t>Sources: docs/design/Design_Document.md §§2–3 and its architecture diagram; frozen src/main.py, src/controller/cli.py, src/model, src/storage/pim_file.py. Speaker: MEMBER_D.</a:t>
+              <a:t>Sources: docs/design/Design_Document.md §§2–3 and its architecture diagram; current src/main.py, src/controller/cli.py, src/model, src/storage/pim_file.py. Speaker: MEMBER_D. Layered design with MVC-style separation: controller uses manager and storage; manager owns four immutable record classes and calls Criterion.matches. Type/Text/Time criteria are leaves; And/Or/Not compose them. Model has no I/O. This keeps rules independently testable.</a:t>
             </a:r>
           </a:p>
         </p:txBody>
@@ -797,7 +797,7 @@
           <a:lstStyle xmlns:a="http://schemas.openxmlformats.org/drawingml/2006/main"/>
           <a:p xmlns:a="http://schemas.openxmlformats.org/drawingml/2006/main">
             <a:r>
-              <a:t>Sources: docs/reports/integration-test-log.md, docs/reports/code-freeze.md, docs/reports/model-coverage-raw.txt and Test_Coverage.md. Speaker: MEMBER_D. Python 3.11 remains unverified.</a:t>
+              <a:t>Sources: docs/reports/integration-test-log.md, docs/reports/independent-review-2026-10-23.md, docs/reports/independent-model-coverage-2026-10-23-python313.txt and Test_Coverage.md. Speaker: MEMBER_D. 2026-10-23: 51 tests passed on Python 3.11.9, 3.12.3 and 3.13.5. Coverage is from Python 3.13.5. See docs/reports/independent-model-coverage-2026-10-23-python313.txt. Development and revision were AI-assisted; the group must review and acknowledge this work.</a:t>
             </a:r>
           </a:p>
         </p:txBody>
@@ -865,7 +865,7 @@
   </p:cSld>
   <p:clrMap bg1="lt1" tx1="dk1" bg2="lt2" tx2="dk2" accent1="accent1" accent2="accent2" accent3="accent3" accent4="accent4" accent5="accent5" accent6="accent6" hlink="hlink" folHlink="folHlink"/>
   <p:sldLayoutIdLst>
-    <p:sldLayoutId xmlns:r="http://schemas.openxmlformats.org/officeDocument/2006/relationships" id="2147483649" r:id="Rbc64c00c324a44d1"/>
+    <p:sldLayoutId xmlns:r="http://schemas.openxmlformats.org/officeDocument/2006/relationships" id="2147483649" r:id="Reb8a38550487423a"/>
   </p:sldLayoutIdLst>
   <p:txStyles>
     <p:titleStyle>
@@ -1445,6 +1445,7 @@
           <a:lstStyle xmlns:a="http://schemas.openxmlformats.org/drawingml/2006/main"/>
           <a:p xmlns:a="http://schemas.openxmlformats.org/drawingml/2006/main">
             <a:pPr>
+              <a:buNone/>
               <a:defRPr sz="4200" b="1">
                 <a:solidFill>
                   <a:srgbClr val="FFFFFF"/>
@@ -1468,6 +1469,7 @@
           </a:p>
           <a:p xmlns:a="http://schemas.openxmlformats.org/drawingml/2006/main">
             <a:pPr>
+              <a:buNone/>
               <a:defRPr sz="4200" b="1">
                 <a:solidFill>
                   <a:srgbClr val="FFFFFF"/>
@@ -1525,6 +1527,7 @@
           <a:lstStyle xmlns:a="http://schemas.openxmlformats.org/drawingml/2006/main"/>
           <a:p xmlns:a="http://schemas.openxmlformats.org/drawingml/2006/main">
             <a:pPr>
+              <a:buNone/>
               <a:defRPr sz="2100" b="0">
                 <a:solidFill>
                   <a:srgbClr val="DDEAF1"/>
@@ -1582,6 +1585,7 @@
           <a:lstStyle xmlns:a="http://schemas.openxmlformats.org/drawingml/2006/main"/>
           <a:p xmlns:a="http://schemas.openxmlformats.org/drawingml/2006/main">
             <a:pPr>
+              <a:buNone/>
               <a:defRPr sz="1650" b="1">
                 <a:solidFill>
                   <a:srgbClr val="FFFFFF"/>
@@ -1639,6 +1643,7 @@
           <a:lstStyle xmlns:a="http://schemas.openxmlformats.org/drawingml/2006/main"/>
           <a:p xmlns:a="http://schemas.openxmlformats.org/drawingml/2006/main">
             <a:pPr>
+              <a:buNone/>
               <a:defRPr sz="1200" b="0">
                 <a:solidFill>
                   <a:srgbClr val="B9CBD7"/>
@@ -1657,7 +1662,7 @@
                 <a:ea typeface="Arial"/>
                 <a:cs typeface="Arial"/>
               </a:rPr>
-              <a:t>Frozen implementation  ·  4d3508d</a:t>
+              <a:t>Review candidate  ·  23 October 2026</a:t>
             </a:r>
           </a:p>
         </p:txBody>
@@ -1725,6 +1730,7 @@
           <a:lstStyle xmlns:a="http://schemas.openxmlformats.org/drawingml/2006/main"/>
           <a:p xmlns:a="http://schemas.openxmlformats.org/drawingml/2006/main">
             <a:pPr>
+              <a:buNone/>
               <a:defRPr sz="3000" b="1">
                 <a:solidFill>
                   <a:srgbClr val="14273E"/>
@@ -1782,6 +1788,7 @@
           <a:lstStyle xmlns:a="http://schemas.openxmlformats.org/drawingml/2006/main"/>
           <a:p xmlns:a="http://schemas.openxmlformats.org/drawingml/2006/main">
             <a:pPr>
+              <a:buNone/>
               <a:defRPr sz="1125" b="0">
                 <a:solidFill>
                   <a:srgbClr val="506574"/>
@@ -1839,6 +1846,7 @@
           <a:lstStyle xmlns:a="http://schemas.openxmlformats.org/drawingml/2006/main"/>
           <a:p xmlns:a="http://schemas.openxmlformats.org/drawingml/2006/main">
             <a:pPr>
+              <a:buNone/>
               <a:defRPr sz="1275" b="1">
                 <a:solidFill>
                   <a:srgbClr val="176B98"/>
@@ -1896,6 +1904,7 @@
           <a:lstStyle xmlns:a="http://schemas.openxmlformats.org/drawingml/2006/main"/>
           <a:p xmlns:a="http://schemas.openxmlformats.org/drawingml/2006/main">
             <a:pPr>
+              <a:buNone/>
               <a:defRPr sz="2100" b="0">
                 <a:solidFill>
                   <a:srgbClr val="14273E"/>
@@ -1953,6 +1962,7 @@
           <a:lstStyle xmlns:a="http://schemas.openxmlformats.org/drawingml/2006/main"/>
           <a:p xmlns:a="http://schemas.openxmlformats.org/drawingml/2006/main">
             <a:pPr>
+              <a:buNone/>
               <a:defRPr sz="1275" b="1">
                 <a:solidFill>
                   <a:srgbClr val="176B98"/>
@@ -2010,6 +2020,7 @@
           <a:lstStyle xmlns:a="http://schemas.openxmlformats.org/drawingml/2006/main"/>
           <a:p xmlns:a="http://schemas.openxmlformats.org/drawingml/2006/main">
             <a:pPr>
+              <a:buNone/>
               <a:defRPr sz="1950" b="0">
                 <a:solidFill>
                   <a:srgbClr val="14273E"/>
@@ -2067,6 +2078,7 @@
           <a:lstStyle xmlns:a="http://schemas.openxmlformats.org/drawingml/2006/main"/>
           <a:p xmlns:a="http://schemas.openxmlformats.org/drawingml/2006/main">
             <a:pPr>
+              <a:buNone/>
               <a:defRPr sz="1275" b="1">
                 <a:solidFill>
                   <a:srgbClr val="176B98"/>
@@ -2085,7 +2097,7 @@
                 <a:ea typeface="Arial"/>
                 <a:cs typeface="Arial"/>
               </a:rPr>
-              <a:t>OBSERVED IN THE FROZEN CLI</a:t>
+              <a:t>OBSERVED CLI OUTPUT (AFTER CREATING NOTE 1)</a:t>
             </a:r>
           </a:p>
         </p:txBody>
@@ -2124,6 +2136,7 @@
           <a:lstStyle xmlns:a="http://schemas.openxmlformats.org/drawingml/2006/main"/>
           <a:p xmlns:a="http://schemas.openxmlformats.org/drawingml/2006/main">
             <a:pPr>
+              <a:buNone/>
               <a:defRPr sz="1800" b="0">
                 <a:solidFill>
                   <a:srgbClr val="14273E"/>
@@ -2147,6 +2160,7 @@
           </a:p>
           <a:p xmlns:a="http://schemas.openxmlformats.org/drawingml/2006/main">
             <a:pPr>
+              <a:buNone/>
               <a:defRPr sz="1800" b="0">
                 <a:solidFill>
                   <a:srgbClr val="14273E"/>
@@ -2170,6 +2184,7 @@
           </a:p>
           <a:p xmlns:a="http://schemas.openxmlformats.org/drawingml/2006/main">
             <a:pPr>
+              <a:buNone/>
               <a:defRPr sz="1800" b="0">
                 <a:solidFill>
                   <a:srgbClr val="14273E"/>
@@ -2193,6 +2208,7 @@
           </a:p>
           <a:p xmlns:a="http://schemas.openxmlformats.org/drawingml/2006/main">
             <a:pPr>
+              <a:buNone/>
               <a:defRPr sz="1800" b="0">
                 <a:solidFill>
                   <a:srgbClr val="14273E"/>
@@ -2216,6 +2232,7 @@
           </a:p>
           <a:p xmlns:a="http://schemas.openxmlformats.org/drawingml/2006/main">
             <a:pPr>
+              <a:buNone/>
               <a:defRPr sz="1800" b="0">
                 <a:solidFill>
                   <a:srgbClr val="14273E"/>
@@ -2302,6 +2319,7 @@
           <a:lstStyle xmlns:a="http://schemas.openxmlformats.org/drawingml/2006/main"/>
           <a:p xmlns:a="http://schemas.openxmlformats.org/drawingml/2006/main">
             <a:pPr>
+              <a:buNone/>
               <a:defRPr sz="3000" b="1">
                 <a:solidFill>
                   <a:srgbClr val="14273E"/>
@@ -2359,6 +2377,7 @@
           <a:lstStyle xmlns:a="http://schemas.openxmlformats.org/drawingml/2006/main"/>
           <a:p xmlns:a="http://schemas.openxmlformats.org/drawingml/2006/main">
             <a:pPr>
+              <a:buNone/>
               <a:defRPr sz="1125" b="0">
                 <a:solidFill>
                   <a:srgbClr val="506574"/>
@@ -2416,6 +2435,7 @@
           <a:lstStyle xmlns:a="http://schemas.openxmlformats.org/drawingml/2006/main"/>
           <a:p xmlns:a="http://schemas.openxmlformats.org/drawingml/2006/main">
             <a:pPr>
+              <a:buNone/>
               <a:defRPr sz="1275" b="1">
                 <a:solidFill>
                   <a:srgbClr val="176B98"/>
@@ -2473,6 +2493,7 @@
           <a:lstStyle xmlns:a="http://schemas.openxmlformats.org/drawingml/2006/main"/>
           <a:p xmlns:a="http://schemas.openxmlformats.org/drawingml/2006/main">
             <a:pPr>
+              <a:buNone/>
               <a:defRPr sz="1800" b="0">
                 <a:solidFill>
                   <a:srgbClr val="14273E"/>
@@ -2496,6 +2517,7 @@
           </a:p>
           <a:p xmlns:a="http://schemas.openxmlformats.org/drawingml/2006/main">
             <a:pPr>
+              <a:buNone/>
               <a:defRPr sz="1800" b="0">
                 <a:solidFill>
                   <a:srgbClr val="14273E"/>
@@ -2553,6 +2575,7 @@
           <a:lstStyle xmlns:a="http://schemas.openxmlformats.org/drawingml/2006/main"/>
           <a:p xmlns:a="http://schemas.openxmlformats.org/drawingml/2006/main">
             <a:pPr>
+              <a:buNone/>
               <a:defRPr sz="2025" b="0">
                 <a:solidFill>
                   <a:srgbClr val="14273E"/>
@@ -2576,6 +2599,7 @@
           </a:p>
           <a:p xmlns:a="http://schemas.openxmlformats.org/drawingml/2006/main">
             <a:pPr>
+              <a:buNone/>
               <a:defRPr sz="2025" b="0">
                 <a:solidFill>
                   <a:srgbClr val="14273E"/>
@@ -2633,6 +2657,7 @@
           <a:lstStyle xmlns:a="http://schemas.openxmlformats.org/drawingml/2006/main"/>
           <a:p xmlns:a="http://schemas.openxmlformats.org/drawingml/2006/main">
             <a:pPr>
+              <a:buNone/>
               <a:defRPr sz="1725" b="0">
                 <a:solidFill>
                   <a:srgbClr val="506574"/>
@@ -2719,6 +2744,7 @@
           <a:lstStyle xmlns:a="http://schemas.openxmlformats.org/drawingml/2006/main"/>
           <a:p xmlns:a="http://schemas.openxmlformats.org/drawingml/2006/main">
             <a:pPr>
+              <a:buNone/>
               <a:defRPr sz="3000" b="1">
                 <a:solidFill>
                   <a:srgbClr val="14273E"/>
@@ -2776,6 +2802,7 @@
           <a:lstStyle xmlns:a="http://schemas.openxmlformats.org/drawingml/2006/main"/>
           <a:p xmlns:a="http://schemas.openxmlformats.org/drawingml/2006/main">
             <a:pPr>
+              <a:buNone/>
               <a:defRPr sz="1125" b="0">
                 <a:solidFill>
                   <a:srgbClr val="506574"/>
@@ -2833,6 +2860,7 @@
           <a:lstStyle xmlns:a="http://schemas.openxmlformats.org/drawingml/2006/main"/>
           <a:p xmlns:a="http://schemas.openxmlformats.org/drawingml/2006/main">
             <a:pPr>
+              <a:buNone/>
               <a:defRPr sz="1275" b="1">
                 <a:solidFill>
                   <a:srgbClr val="176B98"/>
@@ -2890,6 +2918,7 @@
           <a:lstStyle xmlns:a="http://schemas.openxmlformats.org/drawingml/2006/main"/>
           <a:p xmlns:a="http://schemas.openxmlformats.org/drawingml/2006/main">
             <a:pPr>
+              <a:buNone/>
               <a:defRPr sz="2100" b="0">
                 <a:solidFill>
                   <a:srgbClr val="14273E"/>
@@ -2947,6 +2976,7 @@
           <a:lstStyle xmlns:a="http://schemas.openxmlformats.org/drawingml/2006/main"/>
           <a:p xmlns:a="http://schemas.openxmlformats.org/drawingml/2006/main">
             <a:pPr>
+              <a:buNone/>
               <a:defRPr sz="2400" b="0">
                 <a:solidFill>
                   <a:srgbClr val="14273E"/>
@@ -2970,6 +3000,7 @@
           </a:p>
           <a:p xmlns:a="http://schemas.openxmlformats.org/drawingml/2006/main">
             <a:pPr>
+              <a:buNone/>
               <a:defRPr sz="2400" b="0">
                 <a:solidFill>
                   <a:srgbClr val="14273E"/>
@@ -3027,6 +3058,7 @@
           <a:lstStyle xmlns:a="http://schemas.openxmlformats.org/drawingml/2006/main"/>
           <a:p xmlns:a="http://schemas.openxmlformats.org/drawingml/2006/main">
             <a:pPr>
+              <a:buNone/>
               <a:defRPr sz="1275" b="1">
                 <a:solidFill>
                   <a:srgbClr val="176B98"/>
@@ -3084,6 +3116,7 @@
           <a:lstStyle xmlns:a="http://schemas.openxmlformats.org/drawingml/2006/main"/>
           <a:p xmlns:a="http://schemas.openxmlformats.org/drawingml/2006/main">
             <a:pPr>
+              <a:buNone/>
               <a:defRPr sz="1950" b="0">
                 <a:solidFill>
                   <a:srgbClr val="14273E"/>
@@ -3170,6 +3203,7 @@
           <a:lstStyle xmlns:a="http://schemas.openxmlformats.org/drawingml/2006/main"/>
           <a:p xmlns:a="http://schemas.openxmlformats.org/drawingml/2006/main">
             <a:pPr>
+              <a:buNone/>
               <a:defRPr sz="3000" b="1">
                 <a:solidFill>
                   <a:srgbClr val="14273E"/>
@@ -3188,7 +3222,7 @@
                 <a:ea typeface="Arial"/>
                 <a:cs typeface="Arial"/>
               </a:rPr>
-              <a:t>Architecture and components</a:t>
+              <a:t>Layered design and component relationships</a:t>
             </a:r>
           </a:p>
         </p:txBody>
@@ -3227,6 +3261,7 @@
           <a:lstStyle xmlns:a="http://schemas.openxmlformats.org/drawingml/2006/main"/>
           <a:p xmlns:a="http://schemas.openxmlformats.org/drawingml/2006/main">
             <a:pPr>
+              <a:buNone/>
               <a:defRPr sz="1125" b="0">
                 <a:solidFill>
                   <a:srgbClr val="506574"/>
@@ -3252,14 +3287,20 @@
       </p:sp>
       <p:pic>
         <p:nvPicPr>
-          <p:cNvPr id="13" name=""/>
+          <p:cNvPr id="13" name="">
+            <a:extLst xmlns:a="http://schemas.openxmlformats.org/drawingml/2006/main">
+              <a:ext uri="{FF2B5EF4-FFF2-40B4-BE49-F238E27FC236}">
+                <a16:creationId xmlns:a16="http://schemas.microsoft.com/office/drawing/2014/main" id="{87A01DD0-DEA9-4F76-900A-CE59D432E8F7}"/>
+              </a:ext>
+            </a:extLst>
+          </p:cNvPr>
           <p:cNvPicPr>
             <a:picLocks xmlns:a="http://schemas.openxmlformats.org/drawingml/2006/main" noChangeAspect="1"/>
           </p:cNvPicPr>
           <p:nvPr/>
         </p:nvPicPr>
         <p:blipFill>
-          <a:blip xmlns:r="http://schemas.openxmlformats.org/officeDocument/2006/relationships" xmlns:a="http://schemas.openxmlformats.org/drawingml/2006/main" r:embed="R96903c17952c4014"/>
+          <a:blip xmlns:r="http://schemas.openxmlformats.org/officeDocument/2006/relationships" xmlns:a="http://schemas.openxmlformats.org/drawingml/2006/main" r:embed="Rd5cf232b0f4047df"/>
           <a:stretch xmlns:a="http://schemas.openxmlformats.org/drawingml/2006/main"/>
         </p:blipFill>
         <p:spPr>
@@ -3306,6 +3347,7 @@
           <a:lstStyle xmlns:a="http://schemas.openxmlformats.org/drawingml/2006/main"/>
           <a:p xmlns:a="http://schemas.openxmlformats.org/drawingml/2006/main">
             <a:pPr>
+              <a:buNone/>
               <a:defRPr sz="1275" b="1">
                 <a:solidFill>
                   <a:srgbClr val="176B98"/>
@@ -3324,7 +3366,7 @@
                 <a:ea typeface="Arial"/>
                 <a:cs typeface="Arial"/>
               </a:rPr>
-              <a:t>CommandController</a:t>
+              <a:t>CommandController: terminal view + control</a:t>
             </a:r>
           </a:p>
         </p:txBody>
@@ -3346,7 +3388,7 @@
         <p:spPr>
           <a:xfrm xmlns:a="http://schemas.openxmlformats.org/drawingml/2006/main">
             <a:off x="4810125" y="1952625"/>
-            <a:ext cx="6477000" cy="447675"/>
+            <a:ext cx="6477000" cy="666750"/>
           </a:xfrm>
           <a:prstGeom xmlns:a="http://schemas.openxmlformats.org/drawingml/2006/main" prst="rect">
             <a:avLst/>
@@ -3360,28 +3402,60 @@
           <a:bodyPr xmlns:a="http://schemas.openxmlformats.org/drawingml/2006/main">
             <a:noAutofit/>
           </a:bodyPr>
-          <a:lstStyle xmlns:a="http://schemas.openxmlformats.org/drawingml/2006/main"/>
-          <a:p xmlns:a="http://schemas.openxmlformats.org/drawingml/2006/main">
-            <a:pPr>
-              <a:defRPr sz="1800" b="0">
-                <a:solidFill>
-                  <a:srgbClr val="14273E"/>
-                </a:solidFill>
-                <a:latin typeface="Arial"/>
-                <a:ea typeface="Arial"/>
-                <a:cs typeface="Arial"/>
-              </a:defRPr>
-            </a:pPr>
-            <a:r>
-              <a:rPr sz="1800" b="0">
-                <a:solidFill>
-                  <a:srgbClr val="14273E"/>
-                </a:solidFill>
-                <a:latin typeface="Arial"/>
-                <a:ea typeface="Arial"/>
-                <a:cs typeface="Arial"/>
-              </a:rPr>
-              <a:t>Terminal commands and output</a:t>
+          <a:lstStyle xmlns:a="http://schemas.openxmlformats.org/drawingml/2006/main">
+            <a:defPPr>
+              <a:defRPr sz="1725"/>
+            </a:defPPr>
+            <a:lvl1pPr>
+              <a:defRPr sz="1725"/>
+            </a:lvl1pPr>
+            <a:lvl2pPr>
+              <a:defRPr sz="1725"/>
+            </a:lvl2pPr>
+            <a:lvl3pPr>
+              <a:defRPr sz="1725"/>
+            </a:lvl3pPr>
+            <a:lvl4pPr>
+              <a:defRPr sz="1725"/>
+            </a:lvl4pPr>
+            <a:lvl5pPr>
+              <a:defRPr sz="1725"/>
+            </a:lvl5pPr>
+            <a:lvl6pPr>
+              <a:defRPr sz="1725"/>
+            </a:lvl6pPr>
+            <a:lvl7pPr>
+              <a:defRPr sz="1725"/>
+            </a:lvl7pPr>
+            <a:lvl8pPr>
+              <a:defRPr sz="1725"/>
+            </a:lvl8pPr>
+            <a:lvl9pPr>
+              <a:defRPr sz="1725"/>
+            </a:lvl9pPr>
+          </a:lstStyle>
+          <a:p xmlns:a="http://schemas.openxmlformats.org/drawingml/2006/main">
+            <a:pPr>
+              <a:buNone/>
+              <a:defRPr sz="1725" b="0">
+                <a:solidFill>
+                  <a:srgbClr val="14273E"/>
+                </a:solidFill>
+                <a:latin typeface="Arial"/>
+                <a:ea typeface="Arial"/>
+                <a:cs typeface="Arial"/>
+              </a:defRPr>
+            </a:pPr>
+            <a:r>
+              <a:rPr sz="1725" b="0">
+                <a:solidFill>
+                  <a:srgbClr val="14273E"/>
+                </a:solidFill>
+                <a:latin typeface="Arial"/>
+                <a:ea typeface="Arial"/>
+                <a:cs typeface="Arial"/>
+              </a:rPr>
+              <a:t>Calls the model for CRUD/search and storage for files.</a:t>
             </a:r>
           </a:p>
         </p:txBody>
@@ -3420,6 +3494,7 @@
           <a:lstStyle xmlns:a="http://schemas.openxmlformats.org/drawingml/2006/main"/>
           <a:p xmlns:a="http://schemas.openxmlformats.org/drawingml/2006/main">
             <a:pPr>
+              <a:buNone/>
               <a:defRPr sz="1275" b="1">
                 <a:solidFill>
                   <a:srgbClr val="176B98"/>
@@ -3438,7 +3513,7 @@
                 <a:ea typeface="Arial"/>
                 <a:cs typeface="Arial"/>
               </a:rPr>
-              <a:t>PIMManager + model</a:t>
+              <a:t>PIMManager owns immutable record objects</a:t>
             </a:r>
           </a:p>
         </p:txBody>
@@ -3474,28 +3549,60 @@
           <a:bodyPr xmlns:a="http://schemas.openxmlformats.org/drawingml/2006/main">
             <a:noAutofit/>
           </a:bodyPr>
-          <a:lstStyle xmlns:a="http://schemas.openxmlformats.org/drawingml/2006/main"/>
-          <a:p xmlns:a="http://schemas.openxmlformats.org/drawingml/2006/main">
-            <a:pPr>
-              <a:defRPr sz="1800" b="0">
-                <a:solidFill>
-                  <a:srgbClr val="14273E"/>
-                </a:solidFill>
-                <a:latin typeface="Arial"/>
-                <a:ea typeface="Arial"/>
-                <a:cs typeface="Arial"/>
-              </a:defRPr>
-            </a:pPr>
-            <a:r>
-              <a:rPr sz="1800" b="0">
-                <a:solidFill>
-                  <a:srgbClr val="14273E"/>
-                </a:solidFill>
-                <a:latin typeface="Arial"/>
-                <a:ea typeface="Arial"/>
-                <a:cs typeface="Arial"/>
-              </a:rPr>
-              <a:t>Records, ID allocation, validation and search</a:t>
+          <a:lstStyle xmlns:a="http://schemas.openxmlformats.org/drawingml/2006/main">
+            <a:defPPr>
+              <a:defRPr sz="1725"/>
+            </a:defPPr>
+            <a:lvl1pPr>
+              <a:defRPr sz="1725"/>
+            </a:lvl1pPr>
+            <a:lvl2pPr>
+              <a:defRPr sz="1725"/>
+            </a:lvl2pPr>
+            <a:lvl3pPr>
+              <a:defRPr sz="1725"/>
+            </a:lvl3pPr>
+            <a:lvl4pPr>
+              <a:defRPr sz="1725"/>
+            </a:lvl4pPr>
+            <a:lvl5pPr>
+              <a:defRPr sz="1725"/>
+            </a:lvl5pPr>
+            <a:lvl6pPr>
+              <a:defRPr sz="1725"/>
+            </a:lvl6pPr>
+            <a:lvl7pPr>
+              <a:defRPr sz="1725"/>
+            </a:lvl7pPr>
+            <a:lvl8pPr>
+              <a:defRPr sz="1725"/>
+            </a:lvl8pPr>
+            <a:lvl9pPr>
+              <a:defRPr sz="1725"/>
+            </a:lvl9pPr>
+          </a:lstStyle>
+          <a:p xmlns:a="http://schemas.openxmlformats.org/drawingml/2006/main">
+            <a:pPr>
+              <a:buNone/>
+              <a:defRPr sz="1725" b="0">
+                <a:solidFill>
+                  <a:srgbClr val="14273E"/>
+                </a:solidFill>
+                <a:latin typeface="Arial"/>
+                <a:ea typeface="Arial"/>
+                <a:cs typeface="Arial"/>
+              </a:defRPr>
+            </a:pPr>
+            <a:r>
+              <a:rPr sz="1725" b="0">
+                <a:solidFill>
+                  <a:srgbClr val="14273E"/>
+                </a:solidFill>
+                <a:latin typeface="Arial"/>
+                <a:ea typeface="Arial"/>
+                <a:cs typeface="Arial"/>
+              </a:rPr>
+              <a:t>Note, Task, Event and Contact. Search delegates to Criterion.matches(record).</a:t>
             </a:r>
           </a:p>
         </p:txBody>
@@ -3534,6 +3641,7 @@
           <a:lstStyle xmlns:a="http://schemas.openxmlformats.org/drawingml/2006/main"/>
           <a:p xmlns:a="http://schemas.openxmlformats.org/drawingml/2006/main">
             <a:pPr>
+              <a:buNone/>
               <a:defRPr sz="1275" b="1">
                 <a:solidFill>
                   <a:srgbClr val="176B98"/>
@@ -3552,7 +3660,7 @@
                 <a:ea typeface="Arial"/>
                 <a:cs typeface="Arial"/>
               </a:rPr>
-              <a:t>storage.pim_file</a:t>
+              <a:t>storage.pim_file: persistence adapter</a:t>
             </a:r>
           </a:p>
         </p:txBody>
@@ -3588,28 +3696,60 @@
           <a:bodyPr xmlns:a="http://schemas.openxmlformats.org/drawingml/2006/main">
             <a:noAutofit/>
           </a:bodyPr>
-          <a:lstStyle xmlns:a="http://schemas.openxmlformats.org/drawingml/2006/main"/>
-          <a:p xmlns:a="http://schemas.openxmlformats.org/drawingml/2006/main">
-            <a:pPr>
-              <a:defRPr sz="1800" b="0">
-                <a:solidFill>
-                  <a:srgbClr val="14273E"/>
-                </a:solidFill>
-                <a:latin typeface="Arial"/>
-                <a:ea typeface="Arial"/>
-                <a:cs typeface="Arial"/>
-              </a:defRPr>
-            </a:pPr>
-            <a:r>
-              <a:rPr sz="1800" b="0">
-                <a:solidFill>
-                  <a:srgbClr val="14273E"/>
-                </a:solidFill>
-                <a:latin typeface="Arial"/>
-                <a:ea typeface="Arial"/>
-                <a:cs typeface="Arial"/>
-              </a:rPr>
-              <a:t>Versioned .pim save and fully validated load</a:t>
+          <a:lstStyle xmlns:a="http://schemas.openxmlformats.org/drawingml/2006/main">
+            <a:defPPr>
+              <a:defRPr sz="1725"/>
+            </a:defPPr>
+            <a:lvl1pPr>
+              <a:defRPr sz="1725"/>
+            </a:lvl1pPr>
+            <a:lvl2pPr>
+              <a:defRPr sz="1725"/>
+            </a:lvl2pPr>
+            <a:lvl3pPr>
+              <a:defRPr sz="1725"/>
+            </a:lvl3pPr>
+            <a:lvl4pPr>
+              <a:defRPr sz="1725"/>
+            </a:lvl4pPr>
+            <a:lvl5pPr>
+              <a:defRPr sz="1725"/>
+            </a:lvl5pPr>
+            <a:lvl6pPr>
+              <a:defRPr sz="1725"/>
+            </a:lvl6pPr>
+            <a:lvl7pPr>
+              <a:defRPr sz="1725"/>
+            </a:lvl7pPr>
+            <a:lvl8pPr>
+              <a:defRPr sz="1725"/>
+            </a:lvl8pPr>
+            <a:lvl9pPr>
+              <a:defRPr sz="1725"/>
+            </a:lvl9pPr>
+          </a:lstStyle>
+          <a:p xmlns:a="http://schemas.openxmlformats.org/drawingml/2006/main">
+            <a:pPr>
+              <a:buNone/>
+              <a:defRPr sz="1725" b="0">
+                <a:solidFill>
+                  <a:srgbClr val="14273E"/>
+                </a:solidFill>
+                <a:latin typeface="Arial"/>
+                <a:ea typeface="Arial"/>
+                <a:cs typeface="Arial"/>
+              </a:defRPr>
+            </a:pPr>
+            <a:r>
+              <a:rPr sz="1725" b="0">
+                <a:solidFill>
+                  <a:srgbClr val="14273E"/>
+                </a:solidFill>
+                <a:latin typeface="Arial"/>
+                <a:ea typeface="Arial"/>
+                <a:cs typeface="Arial"/>
+              </a:rPr>
+              <a:t>Saves versioned JSON; loads a validated replacement manager.</a:t>
             </a:r>
           </a:p>
         </p:txBody>
@@ -3630,8 +3770,8 @@
         </p:nvSpPr>
         <p:spPr>
           <a:xfrm xmlns:a="http://schemas.openxmlformats.org/drawingml/2006/main">
-            <a:off x="4810125" y="5514975"/>
-            <a:ext cx="6477000" cy="400050"/>
+            <a:off x="4810125" y="5486400"/>
+            <a:ext cx="6477000" cy="666750"/>
           </a:xfrm>
           <a:prstGeom xmlns:a="http://schemas.openxmlformats.org/drawingml/2006/main" prst="rect">
             <a:avLst/>
@@ -3648,6 +3788,7 @@
           <a:lstStyle xmlns:a="http://schemas.openxmlformats.org/drawingml/2006/main"/>
           <a:p xmlns:a="http://schemas.openxmlformats.org/drawingml/2006/main">
             <a:pPr>
+              <a:buNone/>
               <a:defRPr sz="1650" b="0">
                 <a:solidFill>
                   <a:srgbClr val="506574"/>
@@ -3666,7 +3807,7 @@
                 <a:ea typeface="Arial"/>
                 <a:cs typeface="Arial"/>
               </a:rPr>
-              <a:t>The model has no terminal or file I/O.</a:t>
+              <a:t>MVC-style separation keeps model tests independent of terminal and file I/O.</a:t>
             </a:r>
           </a:p>
         </p:txBody>
@@ -3734,6 +3875,7 @@
           <a:lstStyle xmlns:a="http://schemas.openxmlformats.org/drawingml/2006/main"/>
           <a:p xmlns:a="http://schemas.openxmlformats.org/drawingml/2006/main">
             <a:pPr>
+              <a:buNone/>
               <a:defRPr sz="3000" b="1">
                 <a:solidFill>
                   <a:srgbClr val="14273E"/>
@@ -3791,6 +3933,7 @@
           <a:lstStyle xmlns:a="http://schemas.openxmlformats.org/drawingml/2006/main"/>
           <a:p xmlns:a="http://schemas.openxmlformats.org/drawingml/2006/main">
             <a:pPr>
+              <a:buNone/>
               <a:defRPr sz="1125" b="0">
                 <a:solidFill>
                   <a:srgbClr val="506574"/>
@@ -3848,6 +3991,7 @@
           <a:lstStyle xmlns:a="http://schemas.openxmlformats.org/drawingml/2006/main"/>
           <a:p xmlns:a="http://schemas.openxmlformats.org/drawingml/2006/main">
             <a:pPr>
+              <a:buNone/>
               <a:defRPr sz="1275" b="1">
                 <a:solidFill>
                   <a:srgbClr val="176B98"/>
@@ -3905,6 +4049,7 @@
           <a:lstStyle xmlns:a="http://schemas.openxmlformats.org/drawingml/2006/main"/>
           <a:p xmlns:a="http://schemas.openxmlformats.org/drawingml/2006/main">
             <a:pPr>
+              <a:buNone/>
               <a:defRPr sz="2025" b="0">
                 <a:solidFill>
                   <a:srgbClr val="14273E"/>
@@ -3962,6 +4107,7 @@
           <a:lstStyle xmlns:a="http://schemas.openxmlformats.org/drawingml/2006/main"/>
           <a:p xmlns:a="http://schemas.openxmlformats.org/drawingml/2006/main">
             <a:pPr>
+              <a:buNone/>
               <a:defRPr sz="1275" b="1">
                 <a:solidFill>
                   <a:srgbClr val="176B98"/>
@@ -4019,6 +4165,7 @@
           <a:lstStyle xmlns:a="http://schemas.openxmlformats.org/drawingml/2006/main"/>
           <a:p xmlns:a="http://schemas.openxmlformats.org/drawingml/2006/main">
             <a:pPr>
+              <a:buNone/>
               <a:defRPr sz="2025" b="0">
                 <a:solidFill>
                   <a:srgbClr val="14273E"/>
@@ -4076,6 +4223,7 @@
           <a:lstStyle xmlns:a="http://schemas.openxmlformats.org/drawingml/2006/main"/>
           <a:p xmlns:a="http://schemas.openxmlformats.org/drawingml/2006/main">
             <a:pPr>
+              <a:buNone/>
               <a:defRPr sz="1275" b="1">
                 <a:solidFill>
                   <a:srgbClr val="176B98"/>
@@ -4094,7 +4242,7 @@
                 <a:ea typeface="Arial"/>
                 <a:cs typeface="Arial"/>
               </a:rPr>
-              <a:t>WP04 EVIDENCE</a:t>
+              <a:t>VERIFIED 23 OCTOBER 2026</a:t>
             </a:r>
           </a:p>
         </p:txBody>
@@ -4133,6 +4281,7 @@
           <a:lstStyle xmlns:a="http://schemas.openxmlformats.org/drawingml/2006/main"/>
           <a:p xmlns:a="http://schemas.openxmlformats.org/drawingml/2006/main">
             <a:pPr>
+              <a:buNone/>
               <a:defRPr sz="2025" b="1">
                 <a:solidFill>
                   <a:srgbClr val="14273E"/>
@@ -4151,7 +4300,7 @@
                 <a:ea typeface="Arial"/>
                 <a:cs typeface="Arial"/>
               </a:rPr>
-              <a:t>33 tests passed  ·  411/430 model lines covered  ·  95.58%</a:t>
+              <a:t>51 tests passed  ·  416/421 model source lines  ·  98.81%</a:t>
             </a:r>
           </a:p>
         </p:txBody>
@@ -4190,6 +4339,7 @@
           <a:lstStyle xmlns:a="http://schemas.openxmlformats.org/drawingml/2006/main"/>
           <a:p xmlns:a="http://schemas.openxmlformats.org/drawingml/2006/main">
             <a:pPr>
+              <a:buNone/>
               <a:defRPr sz="1650" b="0">
                 <a:solidFill>
                   <a:srgbClr val="506574"/>
@@ -4208,7 +4358,7 @@
                 <a:ea typeface="Arial"/>
                 <a:cs typeface="Arial"/>
               </a:rPr>
-              <a:t>Python 3.11 is a target that has not yet been verified.</a:t>
+              <a:t>Python 3.11.9 / 3.12.3 / 3.13.5; source-line trace excludes 0/None.</a:t>
             </a:r>
           </a:p>
         </p:txBody>

</xml_diff>

<commit_message>
Add usability safeguards and synchronize verified release candidate
</commit_message>
<xml_diff>
--- a/artifacts/presentation/Presentation.pptx
+++ b/artifacts/presentation/Presentation.pptx
@@ -2,18 +2,18 @@
 <file path=ppt/presentation.xml><?xml version="1.0" encoding="utf-8"?>
 <p:presentation xmlns:p="http://schemas.openxmlformats.org/presentationml/2006/main">
   <p:sldMasterIdLst>
-    <p:sldMasterId xmlns:r="http://schemas.openxmlformats.org/officeDocument/2006/relationships" id="2147483648" r:id="Rd1855f23126643f0"/>
+    <p:sldMasterId xmlns:r="http://schemas.openxmlformats.org/officeDocument/2006/relationships" id="2147483648" r:id="Re00434abc72d42ca"/>
   </p:sldMasterIdLst>
   <p:notesMasterIdLst>
-    <p:notesMasterId xmlns:r="http://schemas.openxmlformats.org/officeDocument/2006/relationships" r:id="R6dffc6a71ba641e5"/>
+    <p:notesMasterId xmlns:r="http://schemas.openxmlformats.org/officeDocument/2006/relationships" r:id="Rc239898bf8c4488a"/>
   </p:notesMasterIdLst>
   <p:sldIdLst>
-    <p:sldId xmlns:r="http://schemas.openxmlformats.org/officeDocument/2006/relationships" id="256" r:id="R6b59b217a76a4a4b"/>
-    <p:sldId xmlns:r="http://schemas.openxmlformats.org/officeDocument/2006/relationships" id="257" r:id="R80d1108657b04df6"/>
-    <p:sldId xmlns:r="http://schemas.openxmlformats.org/officeDocument/2006/relationships" id="258" r:id="R2f61f0a200c14ed3"/>
-    <p:sldId xmlns:r="http://schemas.openxmlformats.org/officeDocument/2006/relationships" id="259" r:id="Rab5a167c3a6f4b11"/>
-    <p:sldId xmlns:r="http://schemas.openxmlformats.org/officeDocument/2006/relationships" id="260" r:id="Re41462203bfa4811"/>
-    <p:sldId xmlns:r="http://schemas.openxmlformats.org/officeDocument/2006/relationships" id="261" r:id="R72b7976f67864591"/>
+    <p:sldId xmlns:r="http://schemas.openxmlformats.org/officeDocument/2006/relationships" id="256" r:id="R352bdcf2c3c347d2"/>
+    <p:sldId xmlns:r="http://schemas.openxmlformats.org/officeDocument/2006/relationships" id="257" r:id="R3a2adb09fb8746ea"/>
+    <p:sldId xmlns:r="http://schemas.openxmlformats.org/officeDocument/2006/relationships" id="258" r:id="R1943618c809c41db"/>
+    <p:sldId xmlns:r="http://schemas.openxmlformats.org/officeDocument/2006/relationships" id="259" r:id="R55739b10ff724146"/>
+    <p:sldId xmlns:r="http://schemas.openxmlformats.org/officeDocument/2006/relationships" id="260" r:id="Re3a0591901404751"/>
+    <p:sldId xmlns:r="http://schemas.openxmlformats.org/officeDocument/2006/relationships" id="261" r:id="Rb877deffcf074544"/>
   </p:sldIdLst>
   <p:sldSz cx="12192000" cy="6858000"/>
   <p:notesSz cx="6858000" cy="9144000"/>
@@ -587,7 +587,7 @@
           <a:lstStyle xmlns:a="http://schemas.openxmlformats.org/drawingml/2006/main"/>
           <a:p xmlns:a="http://schemas.openxmlformats.org/drawingml/2006/main">
             <a:r>
-              <a:t>Sources: docs/srs/SRS.md FR-26, FR-28, FR-29, FR-31, FR-33, FR-34, FR-36; docs/manuals/User_Manual.md §5; current src/model/search.py. Speaker: MEMBER_B.</a:t>
+              <a:t>Sources: docs/srs/SRS.md FR-26, FR-28, FR-29, FR-31, FR-33, FR-34, FR-36; docs/manuals/User_Manual.md §5; current src/model/search.py. Speaker: MEMBER_B. Usability revision: help search explains grammar and examples; search errors report one-based Unicode character positions in EXPR, with EOF at length plus one. Source: docs/srs/SRS.md FR-53/54.</a:t>
             </a:r>
           </a:p>
         </p:txBody>
@@ -657,7 +657,7 @@
           <a:lstStyle xmlns:a="http://schemas.openxmlformats.org/drawingml/2006/main"/>
           <a:p xmlns:a="http://schemas.openxmlformats.org/drawingml/2006/main">
             <a:r>
-              <a:t>Sources: docs/srs/SRS.md FR-27 and FR-39; media/demo/demo-expected-output.txt; docs/manuals/User_Manual.md §8. Speaker: MEMBER_C.</a:t>
+              <a:t>Sources: docs/srs/SRS.md FR-27 and FR-39; media/demo/demo-expected-output.txt; docs/manuals/User_Manual.md §8. Speaker: MEMBER_C. Usability revision: unsaved changes block load unless force=true. Exit/EOF warns once without saving. Source: docs/srs/SRS.md FR-51/52 and docs/manuals/User_Manual.md.</a:t>
             </a:r>
           </a:p>
         </p:txBody>
@@ -797,7 +797,7 @@
           <a:lstStyle xmlns:a="http://schemas.openxmlformats.org/drawingml/2006/main"/>
           <a:p xmlns:a="http://schemas.openxmlformats.org/drawingml/2006/main">
             <a:r>
-              <a:t>Sources: docs/reports/integration-test-log.md, docs/reports/independent-review-2026-10-23.md, docs/reports/independent-model-coverage-2026-10-23-python313.txt and Test_Coverage.md. Speaker: MEMBER_D. 2026-10-23: 51 tests passed on Python 3.11.9, 3.12.3 and 3.13.5. Coverage is from Python 3.13.5. See docs/reports/independent-model-coverage-2026-10-23-python313.txt. Development and revision were AI-assisted; the group must review and acknowledge this work.</a:t>
+              <a:t>Sources: docs/reports/integration-test-log.md, docs/reports/usability-release-2026-10-23.md, docs/reports/usability-coverage-2026-10-23-python313.txt and Test_Coverage.md. Speaker: MEMBER_D. 2026-10-23: 86 tests passed on Python 3.11.9, 3.12.3 and 3.13.5. Coverage is from Python 3.13.5. See docs/reports/usability-coverage-2026-10-23-python313.txt. Development and revision were AI-assisted; the group must review and acknowledge this work. The 431/436 figure is model source-line coverage driven by the full 86-method suite. The 32 model unit methods alone cover 430/436 (98.62%) on all three tested versions. No branch coverage is claimed. Sources: docs/reports/Test_Coverage.md; usability-model-only-2026-10-23-python313.txt.</a:t>
             </a:r>
           </a:p>
         </p:txBody>
@@ -865,7 +865,7 @@
   </p:cSld>
   <p:clrMap bg1="lt1" tx1="dk1" bg2="lt2" tx2="dk2" accent1="accent1" accent2="accent2" accent3="accent3" accent4="accent4" accent5="accent5" accent6="accent6" hlink="hlink" folHlink="folHlink"/>
   <p:sldLayoutIdLst>
-    <p:sldLayoutId xmlns:r="http://schemas.openxmlformats.org/officeDocument/2006/relationships" id="2147483649" r:id="Reb8a38550487423a"/>
+    <p:sldLayoutId xmlns:r="http://schemas.openxmlformats.org/officeDocument/2006/relationships" id="2147483649" r:id="Rc9d40842f7f44258"/>
   </p:sldLayoutIdLst>
   <p:txStyles>
     <p:titleStyle>
@@ -3290,7 +3290,7 @@
           <p:cNvPr id="13" name="">
             <a:extLst xmlns:a="http://schemas.openxmlformats.org/drawingml/2006/main">
               <a:ext uri="{FF2B5EF4-FFF2-40B4-BE49-F238E27FC236}">
-                <a16:creationId xmlns:a16="http://schemas.microsoft.com/office/drawing/2014/main" id="{87A01DD0-DEA9-4F76-900A-CE59D432E8F7}"/>
+                <a16:creationId xmlns:a16="http://schemas.microsoft.com/office/drawing/2014/main" id="{9ED50B14-2DA7-4225-8B68-0F6DAB22AFA5}"/>
               </a:ext>
             </a:extLst>
           </p:cNvPr>
@@ -3300,7 +3300,7 @@
           <p:nvPr/>
         </p:nvPicPr>
         <p:blipFill>
-          <a:blip xmlns:r="http://schemas.openxmlformats.org/officeDocument/2006/relationships" xmlns:a="http://schemas.openxmlformats.org/drawingml/2006/main" r:embed="Rd5cf232b0f4047df"/>
+          <a:blip xmlns:r="http://schemas.openxmlformats.org/officeDocument/2006/relationships" xmlns:a="http://schemas.openxmlformats.org/drawingml/2006/main" r:embed="R5b48f63f8f6948ae"/>
           <a:stretch xmlns:a="http://schemas.openxmlformats.org/drawingml/2006/main"/>
         </p:blipFill>
         <p:spPr>
@@ -3407,30 +3407,39 @@
               <a:defRPr sz="1725"/>
             </a:defPPr>
             <a:lvl1pPr>
+              <a:buNone/>
               <a:defRPr sz="1725"/>
             </a:lvl1pPr>
             <a:lvl2pPr>
+              <a:buNone/>
               <a:defRPr sz="1725"/>
             </a:lvl2pPr>
             <a:lvl3pPr>
+              <a:buNone/>
               <a:defRPr sz="1725"/>
             </a:lvl3pPr>
             <a:lvl4pPr>
+              <a:buNone/>
               <a:defRPr sz="1725"/>
             </a:lvl4pPr>
             <a:lvl5pPr>
+              <a:buNone/>
               <a:defRPr sz="1725"/>
             </a:lvl5pPr>
             <a:lvl6pPr>
+              <a:buNone/>
               <a:defRPr sz="1725"/>
             </a:lvl6pPr>
             <a:lvl7pPr>
+              <a:buNone/>
               <a:defRPr sz="1725"/>
             </a:lvl7pPr>
             <a:lvl8pPr>
+              <a:buNone/>
               <a:defRPr sz="1725"/>
             </a:lvl8pPr>
             <a:lvl9pPr>
+              <a:buNone/>
               <a:defRPr sz="1725"/>
             </a:lvl9pPr>
           </a:lstStyle>
@@ -3554,30 +3563,39 @@
               <a:defRPr sz="1725"/>
             </a:defPPr>
             <a:lvl1pPr>
+              <a:buNone/>
               <a:defRPr sz="1725"/>
             </a:lvl1pPr>
             <a:lvl2pPr>
+              <a:buNone/>
               <a:defRPr sz="1725"/>
             </a:lvl2pPr>
             <a:lvl3pPr>
+              <a:buNone/>
               <a:defRPr sz="1725"/>
             </a:lvl3pPr>
             <a:lvl4pPr>
+              <a:buNone/>
               <a:defRPr sz="1725"/>
             </a:lvl4pPr>
             <a:lvl5pPr>
+              <a:buNone/>
               <a:defRPr sz="1725"/>
             </a:lvl5pPr>
             <a:lvl6pPr>
+              <a:buNone/>
               <a:defRPr sz="1725"/>
             </a:lvl6pPr>
             <a:lvl7pPr>
+              <a:buNone/>
               <a:defRPr sz="1725"/>
             </a:lvl7pPr>
             <a:lvl8pPr>
+              <a:buNone/>
               <a:defRPr sz="1725"/>
             </a:lvl8pPr>
             <a:lvl9pPr>
+              <a:buNone/>
               <a:defRPr sz="1725"/>
             </a:lvl9pPr>
           </a:lstStyle>
@@ -3701,30 +3719,39 @@
               <a:defRPr sz="1725"/>
             </a:defPPr>
             <a:lvl1pPr>
+              <a:buNone/>
               <a:defRPr sz="1725"/>
             </a:lvl1pPr>
             <a:lvl2pPr>
+              <a:buNone/>
               <a:defRPr sz="1725"/>
             </a:lvl2pPr>
             <a:lvl3pPr>
+              <a:buNone/>
               <a:defRPr sz="1725"/>
             </a:lvl3pPr>
             <a:lvl4pPr>
+              <a:buNone/>
               <a:defRPr sz="1725"/>
             </a:lvl4pPr>
             <a:lvl5pPr>
+              <a:buNone/>
               <a:defRPr sz="1725"/>
             </a:lvl5pPr>
             <a:lvl6pPr>
+              <a:buNone/>
               <a:defRPr sz="1725"/>
             </a:lvl6pPr>
             <a:lvl7pPr>
+              <a:buNone/>
               <a:defRPr sz="1725"/>
             </a:lvl7pPr>
             <a:lvl8pPr>
+              <a:buNone/>
               <a:defRPr sz="1725"/>
             </a:lvl8pPr>
             <a:lvl9pPr>
+              <a:buNone/>
               <a:defRPr sz="1725"/>
             </a:lvl9pPr>
           </a:lstStyle>
@@ -4300,7 +4327,7 @@
                 <a:ea typeface="Arial"/>
                 <a:cs typeface="Arial"/>
               </a:rPr>
-              <a:t>51 tests passed  ·  416/421 model source lines  ·  98.81%</a:t>
+              <a:t>86 tests passed  ·  431/436 model source lines  ·  98.85%</a:t>
             </a:r>
           </a:p>
         </p:txBody>

</xml_diff>